<commit_message>
Add updates to slides
</commit_message>
<xml_diff>
--- a/updated_2025/slides/cab_persistency_slides.pptx
+++ b/updated_2025/slides/cab_persistency_slides.pptx
@@ -316,7 +316,7 @@
           <a:p>
             <a:fld id="{5BCAD085-E8A6-8845-BD4E-CB4CCA059FC4}" type="datetimeFigureOut">
               <a:rPr lang="en-US" smtClean="0"/>
-              <a:t>3/9/2026</a:t>
+              <a:t>3/10/2026</a:t>
             </a:fld>
             <a:endParaRPr lang="en-US"/>
           </a:p>
@@ -484,7 +484,7 @@
           <a:p>
             <a:fld id="{5BCAD085-E8A6-8845-BD4E-CB4CCA059FC4}" type="datetimeFigureOut">
               <a:rPr lang="en-US" smtClean="0"/>
-              <a:t>3/9/2026</a:t>
+              <a:t>3/10/2026</a:t>
             </a:fld>
             <a:endParaRPr lang="en-US"/>
           </a:p>
@@ -662,7 +662,7 @@
           <a:p>
             <a:fld id="{5BCAD085-E8A6-8845-BD4E-CB4CCA059FC4}" type="datetimeFigureOut">
               <a:rPr lang="en-US" smtClean="0"/>
-              <a:t>3/9/2026</a:t>
+              <a:t>3/10/2026</a:t>
             </a:fld>
             <a:endParaRPr lang="en-US"/>
           </a:p>
@@ -830,7 +830,7 @@
           <a:p>
             <a:fld id="{5BCAD085-E8A6-8845-BD4E-CB4CCA059FC4}" type="datetimeFigureOut">
               <a:rPr lang="en-US" smtClean="0"/>
-              <a:t>3/9/2026</a:t>
+              <a:t>3/10/2026</a:t>
             </a:fld>
             <a:endParaRPr lang="en-US"/>
           </a:p>
@@ -1075,7 +1075,7 @@
           <a:p>
             <a:fld id="{5BCAD085-E8A6-8845-BD4E-CB4CCA059FC4}" type="datetimeFigureOut">
               <a:rPr lang="en-US" smtClean="0"/>
-              <a:t>3/9/2026</a:t>
+              <a:t>3/10/2026</a:t>
             </a:fld>
             <a:endParaRPr lang="en-US"/>
           </a:p>
@@ -1360,7 +1360,7 @@
           <a:p>
             <a:fld id="{5BCAD085-E8A6-8845-BD4E-CB4CCA059FC4}" type="datetimeFigureOut">
               <a:rPr lang="en-US" smtClean="0"/>
-              <a:t>3/9/2026</a:t>
+              <a:t>3/10/2026</a:t>
             </a:fld>
             <a:endParaRPr lang="en-US"/>
           </a:p>
@@ -1779,7 +1779,7 @@
           <a:p>
             <a:fld id="{5BCAD085-E8A6-8845-BD4E-CB4CCA059FC4}" type="datetimeFigureOut">
               <a:rPr lang="en-US" smtClean="0"/>
-              <a:t>3/9/2026</a:t>
+              <a:t>3/10/2026</a:t>
             </a:fld>
             <a:endParaRPr lang="en-US"/>
           </a:p>
@@ -1896,7 +1896,7 @@
           <a:p>
             <a:fld id="{5BCAD085-E8A6-8845-BD4E-CB4CCA059FC4}" type="datetimeFigureOut">
               <a:rPr lang="en-US" smtClean="0"/>
-              <a:t>3/9/2026</a:t>
+              <a:t>3/10/2026</a:t>
             </a:fld>
             <a:endParaRPr lang="en-US"/>
           </a:p>
@@ -1991,7 +1991,7 @@
           <a:p>
             <a:fld id="{5BCAD085-E8A6-8845-BD4E-CB4CCA059FC4}" type="datetimeFigureOut">
               <a:rPr lang="en-US" smtClean="0"/>
-              <a:t>3/9/2026</a:t>
+              <a:t>3/10/2026</a:t>
             </a:fld>
             <a:endParaRPr lang="en-US"/>
           </a:p>
@@ -2266,7 +2266,7 @@
           <a:p>
             <a:fld id="{5BCAD085-E8A6-8845-BD4E-CB4CCA059FC4}" type="datetimeFigureOut">
               <a:rPr lang="en-US" smtClean="0"/>
-              <a:t>3/9/2026</a:t>
+              <a:t>3/10/2026</a:t>
             </a:fld>
             <a:endParaRPr lang="en-US"/>
           </a:p>
@@ -2518,7 +2518,7 @@
           <a:p>
             <a:fld id="{5BCAD085-E8A6-8845-BD4E-CB4CCA059FC4}" type="datetimeFigureOut">
               <a:rPr lang="en-US" smtClean="0"/>
-              <a:t>3/9/2026</a:t>
+              <a:t>3/10/2026</a:t>
             </a:fld>
             <a:endParaRPr lang="en-US"/>
           </a:p>
@@ -2729,7 +2729,7 @@
           <a:p>
             <a:fld id="{5BCAD085-E8A6-8845-BD4E-CB4CCA059FC4}" type="datetimeFigureOut">
               <a:rPr lang="en-US" smtClean="0"/>
-              <a:t>3/9/2026</a:t>
+              <a:t>3/10/2026</a:t>
             </a:fld>
             <a:endParaRPr lang="en-US"/>
           </a:p>
@@ -3624,7 +3624,7 @@
         </p:nvSpPr>
         <p:spPr>
           <a:xfrm>
-            <a:off x="502920" y="2505456"/>
+            <a:off x="502920" y="2363817"/>
             <a:ext cx="11183112" cy="420624"/>
           </a:xfrm>
           <a:prstGeom prst="rect">
@@ -3638,7 +3638,7 @@
           </a:bodyPr>
           <a:lstStyle/>
           <a:p>
-            <a:endParaRPr/>
+            <a:endParaRPr dirty="0"/>
           </a:p>
           <a:p>
             <a:pPr algn="l">
@@ -3647,13 +3647,31 @@
               </a:spcBef>
             </a:pPr>
             <a:r>
-              <a:rPr sz="1400" b="0" i="0">
+              <a:rPr sz="1400" b="0" i="0" dirty="0">
                 <a:solidFill>
                   <a:srgbClr val="1A1A2E"/>
                 </a:solidFill>
                 <a:latin typeface="Calibri"/>
               </a:rPr>
-              <a:t>Fixed exchange rate (dummy):  1 if fixed/pegged arrangement in year t  (Ilzetzki, Reinhart &amp; Rogoff)</a:t>
+              <a:t>Fixed exchange rate (dummy):  1 if fixed/pegged arrangement in year t  (</a:t>
+            </a:r>
+            <a:r>
+              <a:rPr sz="1400" b="0" i="0" dirty="0" err="1">
+                <a:solidFill>
+                  <a:srgbClr val="1A1A2E"/>
+                </a:solidFill>
+                <a:latin typeface="Calibri"/>
+              </a:rPr>
+              <a:t>Ilzetzki</a:t>
+            </a:r>
+            <a:r>
+              <a:rPr sz="1400" b="0" i="0" dirty="0">
+                <a:solidFill>
+                  <a:srgbClr val="1A1A2E"/>
+                </a:solidFill>
+                <a:latin typeface="Calibri"/>
+              </a:rPr>
+              <a:t>, Reinhart &amp; Rogoff)</a:t>
             </a:r>
           </a:p>
         </p:txBody>
@@ -3710,7 +3728,7 @@
         </p:nvSpPr>
         <p:spPr>
           <a:xfrm>
-            <a:off x="502920" y="2980944"/>
+            <a:off x="502920" y="2871216"/>
             <a:ext cx="11183112" cy="420624"/>
           </a:xfrm>
           <a:prstGeom prst="rect">
@@ -3724,7 +3742,7 @@
           </a:bodyPr>
           <a:lstStyle/>
           <a:p>
-            <a:endParaRPr/>
+            <a:endParaRPr dirty="0"/>
           </a:p>
           <a:p>
             <a:pPr algn="l">
@@ -3733,7 +3751,7 @@
               </a:spcBef>
             </a:pPr>
             <a:r>
-              <a:rPr sz="1400" b="0" i="0">
+              <a:rPr sz="1400" b="0" i="0" dirty="0">
                 <a:solidFill>
                   <a:srgbClr val="1A1A2E"/>
                 </a:solidFill>
@@ -3796,7 +3814,7 @@
         </p:nvSpPr>
         <p:spPr>
           <a:xfrm>
-            <a:off x="502920" y="3456432"/>
+            <a:off x="502920" y="3305276"/>
             <a:ext cx="11183112" cy="420624"/>
           </a:xfrm>
           <a:prstGeom prst="rect">
@@ -3810,7 +3828,7 @@
           </a:bodyPr>
           <a:lstStyle/>
           <a:p>
-            <a:endParaRPr/>
+            <a:endParaRPr dirty="0"/>
           </a:p>
           <a:p>
             <a:pPr algn="l">
@@ -3819,7 +3837,7 @@
               </a:spcBef>
             </a:pPr>
             <a:r>
-              <a:rPr sz="1400" b="0" i="0">
+              <a:rPr sz="1400" b="0" i="0" dirty="0">
                 <a:solidFill>
                   <a:srgbClr val="1A1A2E"/>
                 </a:solidFill>
@@ -3882,7 +3900,7 @@
         </p:nvSpPr>
         <p:spPr>
           <a:xfrm>
-            <a:off x="502920" y="3931920"/>
+            <a:off x="502920" y="3771060"/>
             <a:ext cx="11183112" cy="420624"/>
           </a:xfrm>
           <a:prstGeom prst="rect">
@@ -3896,7 +3914,7 @@
           </a:bodyPr>
           <a:lstStyle/>
           <a:p>
-            <a:endParaRPr/>
+            <a:endParaRPr dirty="0"/>
           </a:p>
           <a:p>
             <a:pPr algn="l">
@@ -3905,7 +3923,7 @@
               </a:spcBef>
             </a:pPr>
             <a:r>
-              <a:rPr sz="1400" b="0" i="0">
+              <a:rPr sz="1400" b="0" i="0" dirty="0">
                 <a:solidFill>
                   <a:srgbClr val="1A1A2E"/>
                 </a:solidFill>
@@ -3968,7 +3986,7 @@
         </p:nvSpPr>
         <p:spPr>
           <a:xfrm>
-            <a:off x="502920" y="4407408"/>
+            <a:off x="502856" y="4240949"/>
             <a:ext cx="11183112" cy="420624"/>
           </a:xfrm>
           <a:prstGeom prst="rect">
@@ -3982,7 +4000,7 @@
           </a:bodyPr>
           <a:lstStyle/>
           <a:p>
-            <a:endParaRPr/>
+            <a:endParaRPr dirty="0"/>
           </a:p>
           <a:p>
             <a:pPr algn="l">
@@ -3991,7 +4009,7 @@
               </a:spcBef>
             </a:pPr>
             <a:r>
-              <a:rPr sz="1400" b="0" i="0">
+              <a:rPr sz="1400" b="0" i="0" dirty="0">
                 <a:solidFill>
                   <a:srgbClr val="1A1A2E"/>
                 </a:solidFill>
@@ -4054,7 +4072,7 @@
         </p:nvSpPr>
         <p:spPr>
           <a:xfrm>
-            <a:off x="502920" y="4882896"/>
+            <a:off x="502920" y="4716904"/>
             <a:ext cx="11183112" cy="420624"/>
           </a:xfrm>
           <a:prstGeom prst="rect">
@@ -4068,7 +4086,7 @@
           </a:bodyPr>
           <a:lstStyle/>
           <a:p>
-            <a:endParaRPr/>
+            <a:endParaRPr dirty="0"/>
           </a:p>
           <a:p>
             <a:pPr algn="l">
@@ -4077,7 +4095,7 @@
               </a:spcBef>
             </a:pPr>
             <a:r>
-              <a:rPr sz="1400" b="0" i="0">
+              <a:rPr sz="1400" b="0" i="0" dirty="0">
                 <a:solidFill>
                   <a:srgbClr val="1A1A2E"/>
                 </a:solidFill>
@@ -4327,7 +4345,7 @@
         </p:nvSpPr>
         <p:spPr>
           <a:xfrm>
-            <a:off x="411480" y="1691640"/>
+            <a:off x="411353" y="1887513"/>
             <a:ext cx="11365992" cy="347472"/>
           </a:xfrm>
           <a:prstGeom prst="rect">
@@ -4371,7 +4389,7 @@
         </p:nvSpPr>
         <p:spPr>
           <a:xfrm>
-            <a:off x="502920" y="1728216"/>
+            <a:off x="502793" y="1895455"/>
             <a:ext cx="11183112" cy="292608"/>
           </a:xfrm>
           <a:prstGeom prst="rect">
@@ -4386,7 +4404,7 @@
           <a:lstStyle/>
           <a:p>
             <a:r>
-              <a:rPr sz="1300" b="1">
+              <a:rPr sz="1300" b="1" dirty="0">
                 <a:solidFill>
                   <a:srgbClr val="FFFFFF"/>
                 </a:solidFill>
@@ -4405,7 +4423,7 @@
         </p:nvSpPr>
         <p:spPr>
           <a:xfrm>
-            <a:off x="411480" y="2039112"/>
+            <a:off x="411480" y="2309910"/>
             <a:ext cx="11365992" cy="475488"/>
           </a:xfrm>
           <a:prstGeom prst="rect">
@@ -4449,7 +4467,7 @@
         </p:nvSpPr>
         <p:spPr>
           <a:xfrm>
-            <a:off x="502920" y="2121408"/>
+            <a:off x="502920" y="2316977"/>
             <a:ext cx="11183112" cy="384048"/>
           </a:xfrm>
           <a:prstGeom prst="rect">
@@ -4464,7 +4482,7 @@
           <a:lstStyle/>
           <a:p>
             <a:r>
-              <a:rPr sz="1400">
+              <a:rPr sz="1400" dirty="0">
                 <a:solidFill>
                   <a:srgbClr val="1A1A2E"/>
                 </a:solidFill>
@@ -4483,7 +4501,7 @@
         </p:nvSpPr>
         <p:spPr>
           <a:xfrm>
-            <a:off x="411480" y="2514600"/>
+            <a:off x="411353" y="2785398"/>
             <a:ext cx="11365992" cy="475488"/>
           </a:xfrm>
           <a:prstGeom prst="rect">
@@ -4527,7 +4545,7 @@
         </p:nvSpPr>
         <p:spPr>
           <a:xfrm>
-            <a:off x="502920" y="2596896"/>
+            <a:off x="502920" y="2790692"/>
             <a:ext cx="11183112" cy="384048"/>
           </a:xfrm>
           <a:prstGeom prst="rect">
@@ -4542,7 +4560,7 @@
           <a:lstStyle/>
           <a:p>
             <a:r>
-              <a:rPr sz="1400">
+              <a:rPr sz="1400" dirty="0">
                 <a:solidFill>
                   <a:srgbClr val="1A1A2E"/>
                 </a:solidFill>
@@ -4561,7 +4579,7 @@
         </p:nvSpPr>
         <p:spPr>
           <a:xfrm>
-            <a:off x="411480" y="2990088"/>
+            <a:off x="411480" y="3214862"/>
             <a:ext cx="11365992" cy="475488"/>
           </a:xfrm>
           <a:prstGeom prst="rect">
@@ -4605,7 +4623,7 @@
         </p:nvSpPr>
         <p:spPr>
           <a:xfrm>
-            <a:off x="502920" y="3072384"/>
+            <a:off x="502856" y="3316519"/>
             <a:ext cx="11183112" cy="384048"/>
           </a:xfrm>
           <a:prstGeom prst="rect">
@@ -4620,7 +4638,7 @@
           <a:lstStyle/>
           <a:p>
             <a:r>
-              <a:rPr sz="1400">
+              <a:rPr sz="1400" dirty="0">
                 <a:solidFill>
                   <a:srgbClr val="1A1A2E"/>
                 </a:solidFill>
@@ -4639,7 +4657,7 @@
         </p:nvSpPr>
         <p:spPr>
           <a:xfrm>
-            <a:off x="411480" y="3465576"/>
+            <a:off x="411416" y="3716010"/>
             <a:ext cx="11365992" cy="475488"/>
           </a:xfrm>
           <a:prstGeom prst="rect">
@@ -4683,7 +4701,7 @@
         </p:nvSpPr>
         <p:spPr>
           <a:xfrm>
-            <a:off x="502920" y="3547872"/>
+            <a:off x="502856" y="3716010"/>
             <a:ext cx="11183112" cy="384048"/>
           </a:xfrm>
           <a:prstGeom prst="rect">
@@ -4698,13 +4716,49 @@
           <a:lstStyle/>
           <a:p>
             <a:r>
-              <a:rPr sz="1400">
+              <a:rPr sz="1400" dirty="0">
                 <a:solidFill>
                   <a:srgbClr val="1A1A2E"/>
                 </a:solidFill>
                 <a:latin typeface="Calibri"/>
               </a:rPr>
-              <a:t>Current account deficit                       n.s.                      n.s.          </a:t>
+              <a:t>Current account deficit                       </a:t>
+            </a:r>
+            <a:r>
+              <a:rPr sz="1400" dirty="0" err="1">
+                <a:solidFill>
+                  <a:srgbClr val="1A1A2E"/>
+                </a:solidFill>
+                <a:latin typeface="Calibri"/>
+              </a:rPr>
+              <a:t>n.s</a:t>
+            </a:r>
+            <a:r>
+              <a:rPr sz="1400" dirty="0">
+                <a:solidFill>
+                  <a:srgbClr val="1A1A2E"/>
+                </a:solidFill>
+                <a:latin typeface="Calibri"/>
+              </a:rPr>
+              <a:t>.                      </a:t>
+            </a:r>
+            <a:r>
+              <a:rPr sz="1400" dirty="0" err="1">
+                <a:solidFill>
+                  <a:srgbClr val="1A1A2E"/>
+                </a:solidFill>
+                <a:latin typeface="Calibri"/>
+              </a:rPr>
+              <a:t>n.s</a:t>
+            </a:r>
+            <a:r>
+              <a:rPr sz="1400" dirty="0">
+                <a:solidFill>
+                  <a:srgbClr val="1A1A2E"/>
+                </a:solidFill>
+                <a:latin typeface="Calibri"/>
+              </a:rPr>
+              <a:t>.          </a:t>
             </a:r>
           </a:p>
         </p:txBody>
@@ -4717,7 +4771,7 @@
         </p:nvSpPr>
         <p:spPr>
           <a:xfrm>
-            <a:off x="411480" y="3941064"/>
+            <a:off x="411416" y="4165092"/>
             <a:ext cx="11365992" cy="475488"/>
           </a:xfrm>
           <a:prstGeom prst="rect">
@@ -4761,7 +4815,7 @@
         </p:nvSpPr>
         <p:spPr>
           <a:xfrm>
-            <a:off x="502920" y="4023360"/>
+            <a:off x="411480" y="4236098"/>
             <a:ext cx="11183112" cy="384048"/>
           </a:xfrm>
           <a:prstGeom prst="rect">
@@ -4776,13 +4830,49 @@
           <a:lstStyle/>
           <a:p>
             <a:r>
-              <a:rPr sz="1400">
+              <a:rPr sz="1400" dirty="0">
                 <a:solidFill>
                   <a:srgbClr val="1A1A2E"/>
                 </a:solidFill>
                 <a:latin typeface="Calibri"/>
               </a:rPr>
-              <a:t>Commodity exporter                            n.s.                      n.s.          </a:t>
+              <a:t>Commodity exporter                            </a:t>
+            </a:r>
+            <a:r>
+              <a:rPr sz="1400" dirty="0" err="1">
+                <a:solidFill>
+                  <a:srgbClr val="1A1A2E"/>
+                </a:solidFill>
+                <a:latin typeface="Calibri"/>
+              </a:rPr>
+              <a:t>n.s</a:t>
+            </a:r>
+            <a:r>
+              <a:rPr sz="1400" dirty="0">
+                <a:solidFill>
+                  <a:srgbClr val="1A1A2E"/>
+                </a:solidFill>
+                <a:latin typeface="Calibri"/>
+              </a:rPr>
+              <a:t>.                      </a:t>
+            </a:r>
+            <a:r>
+              <a:rPr sz="1400" dirty="0" err="1">
+                <a:solidFill>
+                  <a:srgbClr val="1A1A2E"/>
+                </a:solidFill>
+                <a:latin typeface="Calibri"/>
+              </a:rPr>
+              <a:t>n.s</a:t>
+            </a:r>
+            <a:r>
+              <a:rPr sz="1400" dirty="0">
+                <a:solidFill>
+                  <a:srgbClr val="1A1A2E"/>
+                </a:solidFill>
+                <a:latin typeface="Calibri"/>
+              </a:rPr>
+              <a:t>.          </a:t>
             </a:r>
           </a:p>
         </p:txBody>
@@ -4795,7 +4885,7 @@
         </p:nvSpPr>
         <p:spPr>
           <a:xfrm>
-            <a:off x="411480" y="4416552"/>
+            <a:off x="411480" y="4659614"/>
             <a:ext cx="11365992" cy="475488"/>
           </a:xfrm>
           <a:prstGeom prst="rect">
@@ -4839,7 +4929,7 @@
         </p:nvSpPr>
         <p:spPr>
           <a:xfrm>
-            <a:off x="502920" y="4498848"/>
+            <a:off x="502856" y="4665866"/>
             <a:ext cx="11183112" cy="384048"/>
           </a:xfrm>
           <a:prstGeom prst="rect">
@@ -4854,13 +4944,49 @@
           <a:lstStyle/>
           <a:p>
             <a:r>
-              <a:rPr sz="1400">
+              <a:rPr sz="1400" dirty="0">
                 <a:solidFill>
                   <a:srgbClr val="1A1A2E"/>
                 </a:solidFill>
                 <a:latin typeface="Calibri"/>
               </a:rPr>
-              <a:t>Fiscal balance (t−1)                          n.s.                      n.s.          </a:t>
+              <a:t>Fiscal balance (t−1)                          </a:t>
+            </a:r>
+            <a:r>
+              <a:rPr sz="1400" dirty="0" err="1">
+                <a:solidFill>
+                  <a:srgbClr val="1A1A2E"/>
+                </a:solidFill>
+                <a:latin typeface="Calibri"/>
+              </a:rPr>
+              <a:t>n.s</a:t>
+            </a:r>
+            <a:r>
+              <a:rPr sz="1400" dirty="0">
+                <a:solidFill>
+                  <a:srgbClr val="1A1A2E"/>
+                </a:solidFill>
+                <a:latin typeface="Calibri"/>
+              </a:rPr>
+              <a:t>.                      </a:t>
+            </a:r>
+            <a:r>
+              <a:rPr sz="1400" dirty="0" err="1">
+                <a:solidFill>
+                  <a:srgbClr val="1A1A2E"/>
+                </a:solidFill>
+                <a:latin typeface="Calibri"/>
+              </a:rPr>
+              <a:t>n.s</a:t>
+            </a:r>
+            <a:r>
+              <a:rPr sz="1400" dirty="0">
+                <a:solidFill>
+                  <a:srgbClr val="1A1A2E"/>
+                </a:solidFill>
+                <a:latin typeface="Calibri"/>
+              </a:rPr>
+              <a:t>.          </a:t>
             </a:r>
           </a:p>
         </p:txBody>
@@ -6434,7 +6560,7 @@
         </p:nvSpPr>
         <p:spPr>
           <a:xfrm>
-            <a:off x="411480" y="3794760"/>
+            <a:off x="411480" y="4009644"/>
             <a:ext cx="5303520" cy="649224"/>
           </a:xfrm>
           <a:prstGeom prst="rect">
@@ -6478,7 +6604,7 @@
         </p:nvSpPr>
         <p:spPr>
           <a:xfrm>
-            <a:off x="502920" y="3603762"/>
+            <a:off x="502920" y="3817620"/>
             <a:ext cx="5120640" cy="612648"/>
           </a:xfrm>
           <a:prstGeom prst="rect">
@@ -11139,7 +11265,7 @@
         </p:nvSpPr>
         <p:spPr>
           <a:xfrm>
-            <a:off x="411480" y="1737360"/>
+            <a:off x="405322" y="2232351"/>
             <a:ext cx="5303520" cy="731520"/>
           </a:xfrm>
           <a:prstGeom prst="rect">
@@ -11183,8 +11309,8 @@
         </p:nvSpPr>
         <p:spPr>
           <a:xfrm>
-            <a:off x="502920" y="1783080"/>
-            <a:ext cx="5120640" cy="685800"/>
+            <a:off x="496762" y="2184065"/>
+            <a:ext cx="5120640" cy="784830"/>
           </a:xfrm>
           <a:prstGeom prst="rect">
             <a:avLst/>
@@ -11197,7 +11323,7 @@
           </a:bodyPr>
           <a:lstStyle/>
           <a:p>
-            <a:endParaRPr/>
+            <a:endParaRPr dirty="0"/>
           </a:p>
           <a:p>
             <a:pPr algn="l">
@@ -11206,7 +11332,7 @@
               </a:spcBef>
             </a:pPr>
             <a:r>
-              <a:rPr sz="1400" b="1" i="0">
+              <a:rPr sz="1400" b="1" i="0" dirty="0">
                 <a:solidFill>
                   <a:srgbClr val="1F3864"/>
                 </a:solidFill>
@@ -11222,14 +11348,83 @@
               </a:spcBef>
             </a:pPr>
             <a:r>
-              <a:rPr sz="1300" b="0" i="0">
+              <a:rPr sz="1300" b="0" i="0" dirty="0">
                 <a:solidFill>
                   <a:srgbClr val="1A1A2E"/>
                 </a:solidFill>
                 <a:latin typeface="Calibri"/>
               </a:rPr>
-              <a:t>54% UnitR  |  45% Stat  |   1% Expl</a:t>
-            </a:r>
+              <a:t>54% Unit</a:t>
+            </a:r>
+            <a:r>
+              <a:rPr lang="en-US" sz="1300" b="0" i="0" dirty="0">
+                <a:solidFill>
+                  <a:srgbClr val="1A1A2E"/>
+                </a:solidFill>
+                <a:latin typeface="Calibri"/>
+              </a:rPr>
+              <a:t> </a:t>
+            </a:r>
+            <a:r>
+              <a:rPr sz="1300" b="0" i="0" dirty="0">
+                <a:solidFill>
+                  <a:srgbClr val="1A1A2E"/>
+                </a:solidFill>
+                <a:latin typeface="Calibri"/>
+              </a:rPr>
+              <a:t>R</a:t>
+            </a:r>
+            <a:r>
+              <a:rPr lang="en-US" sz="1300" b="0" i="0" dirty="0">
+                <a:solidFill>
+                  <a:srgbClr val="1A1A2E"/>
+                </a:solidFill>
+                <a:latin typeface="Calibri"/>
+              </a:rPr>
+              <a:t>oot</a:t>
+            </a:r>
+            <a:r>
+              <a:rPr sz="1300" b="0" i="0" dirty="0">
+                <a:solidFill>
+                  <a:srgbClr val="1A1A2E"/>
+                </a:solidFill>
+                <a:latin typeface="Calibri"/>
+              </a:rPr>
+              <a:t>  |  45% Stat</a:t>
+            </a:r>
+            <a:r>
+              <a:rPr lang="en-US" sz="1300" b="0" i="0" dirty="0">
+                <a:solidFill>
+                  <a:srgbClr val="1A1A2E"/>
+                </a:solidFill>
+                <a:latin typeface="Calibri"/>
+              </a:rPr>
+              <a:t>ionary</a:t>
+            </a:r>
+            <a:r>
+              <a:rPr sz="1300" b="0" i="0" dirty="0">
+                <a:solidFill>
+                  <a:srgbClr val="1A1A2E"/>
+                </a:solidFill>
+                <a:latin typeface="Calibri"/>
+              </a:rPr>
+              <a:t>  |   1% Expl</a:t>
+            </a:r>
+            <a:r>
+              <a:rPr lang="en-US" sz="1300" b="0" i="0" dirty="0">
+                <a:solidFill>
+                  <a:srgbClr val="1A1A2E"/>
+                </a:solidFill>
+                <a:latin typeface="Calibri"/>
+              </a:rPr>
+              <a:t>osive</a:t>
+            </a:r>
+            <a:endParaRPr sz="1300" b="0" i="0" dirty="0">
+              <a:solidFill>
+                <a:srgbClr val="1A1A2E"/>
+              </a:solidFill>
+              <a:latin typeface="Calibri"/>
+            </a:endParaRPr>
           </a:p>
         </p:txBody>
       </p:sp>
@@ -11241,7 +11436,7 @@
         </p:nvSpPr>
         <p:spPr>
           <a:xfrm>
-            <a:off x="411480" y="2514600"/>
+            <a:off x="411480" y="2992326"/>
             <a:ext cx="5303520" cy="731520"/>
           </a:xfrm>
           <a:prstGeom prst="rect">
@@ -11285,8 +11480,8 @@
         </p:nvSpPr>
         <p:spPr>
           <a:xfrm>
-            <a:off x="502920" y="2560320"/>
-            <a:ext cx="5120640" cy="685800"/>
+            <a:off x="502920" y="2884092"/>
+            <a:ext cx="5120640" cy="784830"/>
           </a:xfrm>
           <a:prstGeom prst="rect">
             <a:avLst/>
@@ -11299,7 +11494,7 @@
           </a:bodyPr>
           <a:lstStyle/>
           <a:p>
-            <a:endParaRPr/>
+            <a:endParaRPr dirty="0"/>
           </a:p>
           <a:p>
             <a:pPr algn="l">
@@ -11308,7 +11503,7 @@
               </a:spcBef>
             </a:pPr>
             <a:r>
-              <a:rPr sz="1400" b="1" i="0">
+              <a:rPr sz="1400" b="1" i="0" dirty="0">
                 <a:solidFill>
                   <a:srgbClr val="1F3864"/>
                 </a:solidFill>
@@ -11324,14 +11519,83 @@
               </a:spcBef>
             </a:pPr>
             <a:r>
-              <a:rPr sz="1300" b="0" i="0">
+              <a:rPr sz="1300" b="0" i="0" dirty="0">
                 <a:solidFill>
                   <a:srgbClr val="1A1A2E"/>
                 </a:solidFill>
                 <a:latin typeface="Calibri"/>
               </a:rPr>
-              <a:t>56% UnitR  |  32% Stat  |  12% Expl</a:t>
-            </a:r>
+              <a:t>56% Unit</a:t>
+            </a:r>
+            <a:r>
+              <a:rPr lang="en-US" sz="1300" b="0" i="0" dirty="0">
+                <a:solidFill>
+                  <a:srgbClr val="1A1A2E"/>
+                </a:solidFill>
+                <a:latin typeface="Calibri"/>
+              </a:rPr>
+              <a:t> </a:t>
+            </a:r>
+            <a:r>
+              <a:rPr sz="1300" b="0" i="0" dirty="0">
+                <a:solidFill>
+                  <a:srgbClr val="1A1A2E"/>
+                </a:solidFill>
+                <a:latin typeface="Calibri"/>
+              </a:rPr>
+              <a:t>R</a:t>
+            </a:r>
+            <a:r>
+              <a:rPr lang="en-US" sz="1300" b="0" i="0" dirty="0">
+                <a:solidFill>
+                  <a:srgbClr val="1A1A2E"/>
+                </a:solidFill>
+                <a:latin typeface="Calibri"/>
+              </a:rPr>
+              <a:t>oot</a:t>
+            </a:r>
+            <a:r>
+              <a:rPr sz="1300" b="0" i="0" dirty="0">
+                <a:solidFill>
+                  <a:srgbClr val="1A1A2E"/>
+                </a:solidFill>
+                <a:latin typeface="Calibri"/>
+              </a:rPr>
+              <a:t>  |  32% Stat</a:t>
+            </a:r>
+            <a:r>
+              <a:rPr lang="en-US" sz="1300" b="0" i="0" dirty="0">
+                <a:solidFill>
+                  <a:srgbClr val="1A1A2E"/>
+                </a:solidFill>
+                <a:latin typeface="Calibri"/>
+              </a:rPr>
+              <a:t>ionary</a:t>
+            </a:r>
+            <a:r>
+              <a:rPr sz="1300" b="0" i="0" dirty="0">
+                <a:solidFill>
+                  <a:srgbClr val="1A1A2E"/>
+                </a:solidFill>
+                <a:latin typeface="Calibri"/>
+              </a:rPr>
+              <a:t>  |  12% Expl</a:t>
+            </a:r>
+            <a:r>
+              <a:rPr lang="en-US" sz="1300" b="0" i="0" dirty="0">
+                <a:solidFill>
+                  <a:srgbClr val="1A1A2E"/>
+                </a:solidFill>
+                <a:latin typeface="Calibri"/>
+              </a:rPr>
+              <a:t>osive</a:t>
+            </a:r>
+            <a:endParaRPr sz="1300" b="0" i="0" dirty="0">
+              <a:solidFill>
+                <a:srgbClr val="1A1A2E"/>
+              </a:solidFill>
+              <a:latin typeface="Calibri"/>
+            </a:endParaRPr>
           </a:p>
         </p:txBody>
       </p:sp>
@@ -11343,7 +11607,7 @@
         </p:nvSpPr>
         <p:spPr>
           <a:xfrm>
-            <a:off x="411480" y="3291840"/>
+            <a:off x="414279" y="3703320"/>
             <a:ext cx="5303520" cy="731520"/>
           </a:xfrm>
           <a:prstGeom prst="rect">
@@ -11387,8 +11651,8 @@
         </p:nvSpPr>
         <p:spPr>
           <a:xfrm>
-            <a:off x="502920" y="3337560"/>
-            <a:ext cx="5120640" cy="685800"/>
+            <a:off x="496762" y="3667057"/>
+            <a:ext cx="5120640" cy="784830"/>
           </a:xfrm>
           <a:prstGeom prst="rect">
             <a:avLst/>
@@ -11401,7 +11665,7 @@
           </a:bodyPr>
           <a:lstStyle/>
           <a:p>
-            <a:endParaRPr/>
+            <a:endParaRPr dirty="0"/>
           </a:p>
           <a:p>
             <a:pPr algn="l">
@@ -11410,7 +11674,7 @@
               </a:spcBef>
             </a:pPr>
             <a:r>
-              <a:rPr sz="1400" b="1" i="0">
+              <a:rPr sz="1400" b="1" i="0" dirty="0">
                 <a:solidFill>
                   <a:srgbClr val="1F3864"/>
                 </a:solidFill>
@@ -11426,13 +11690,31 @@
               </a:spcBef>
             </a:pPr>
             <a:r>
-              <a:rPr sz="1300" b="0" i="0">
+              <a:rPr sz="1300" b="0" i="0" dirty="0">
                 <a:solidFill>
                   <a:srgbClr val="1A1A2E"/>
                 </a:solidFill>
                 <a:latin typeface="Calibri"/>
               </a:rPr>
-              <a:t>Similar to emerging; elevated explosive share</a:t>
+              <a:t>Similar</a:t>
+            </a:r>
+            <a:r>
+              <a:rPr lang="en-US" sz="1300" b="0" i="0" dirty="0">
+                <a:solidFill>
+                  <a:srgbClr val="1A1A2E"/>
+                </a:solidFill>
+                <a:latin typeface="Calibri"/>
+              </a:rPr>
+              <a:t> </a:t>
+            </a:r>
+            <a:r>
+              <a:rPr sz="1300" b="0" i="0" dirty="0">
+                <a:solidFill>
+                  <a:srgbClr val="1A1A2E"/>
+                </a:solidFill>
+                <a:latin typeface="Calibri"/>
+              </a:rPr>
+              <a:t>to emerging; elevated explosive share</a:t>
             </a:r>
           </a:p>
         </p:txBody>

</xml_diff>